<commit_message>
Actualiza .gitignore para incluir archivos .pptx y modifica archivos de firma digital
</commit_message>
<xml_diff>
--- a/assets/Firma Digital/Firma IM_Genérica_Personal.pptx
+++ b/assets/Firma Digital/Firma IM_Genérica_Personal.pptx
@@ -2781,6 +2781,7 @@
               </a:ext>
             </a:extLst>
           </a:blip>
+          <a:srcRect b="20792"/>
           <a:stretch>
             <a:fillRect/>
           </a:stretch>
@@ -2788,7 +2789,7 @@
         <p:spPr>
           <a:xfrm>
             <a:off x="2791" y="0"/>
-            <a:ext cx="12694418" cy="4813300"/>
+            <a:ext cx="12694418" cy="3812594"/>
           </a:xfrm>
           <a:prstGeom prst="rect">
             <a:avLst/>
@@ -3209,420 +3210,6 @@
           </a:p>
         </p:txBody>
       </p:sp>
-      <p:sp>
-        <p:nvSpPr>
-          <p:cNvPr id="16493" name="object 16493">
-            <a:extLst>
-              <a:ext uri="{FF2B5EF4-FFF2-40B4-BE49-F238E27FC236}">
-                <a16:creationId xmlns:a16="http://schemas.microsoft.com/office/drawing/2014/main" id="{FB3D1956-3B44-E20C-0B84-9E7BF4EAD5E5}"/>
-              </a:ext>
-            </a:extLst>
-          </p:cNvPr>
-          <p:cNvSpPr txBox="1">
-            <a:spLocks noGrp="1"/>
-          </p:cNvSpPr>
-          <p:nvPr>
-            <p:ph type="ftr" sz="quarter" idx="5"/>
-          </p:nvPr>
-        </p:nvSpPr>
-        <p:spPr>
-          <a:xfrm>
-            <a:off x="2357945" y="4164094"/>
-            <a:ext cx="1634489" cy="235321"/>
-          </a:xfrm>
-          <a:prstGeom prst="rect">
-            <a:avLst/>
-          </a:prstGeom>
-        </p:spPr>
-        <p:txBody>
-          <a:bodyPr vert="horz" wrap="square" lIns="0" tIns="4445" rIns="0" bIns="0" rtlCol="0">
-            <a:spAutoFit/>
-          </a:bodyPr>
-          <a:lstStyle/>
-          <a:p>
-            <a:pPr marL="12700">
-              <a:lnSpc>
-                <a:spcPct val="100000"/>
-              </a:lnSpc>
-              <a:spcBef>
-                <a:spcPts val="35"/>
-              </a:spcBef>
-            </a:pPr>
-            <a:r>
-              <a:rPr>
-                <a:latin typeface="Unageo light" pitchFamily="2" charset="0"/>
-              </a:rPr>
-              <a:t>601 8766500 Ext. </a:t>
-            </a:r>
-            <a:r>
-              <a:rPr spc="-50">
-                <a:latin typeface="Unageo light" pitchFamily="2" charset="0"/>
-              </a:rPr>
-              <a:t>2</a:t>
-            </a:r>
-          </a:p>
-        </p:txBody>
-      </p:sp>
-      <p:sp>
-        <p:nvSpPr>
-          <p:cNvPr id="16490" name="object 16490">
-            <a:extLst>
-              <a:ext uri="{FF2B5EF4-FFF2-40B4-BE49-F238E27FC236}">
-                <a16:creationId xmlns:a16="http://schemas.microsoft.com/office/drawing/2014/main" id="{9C734E03-7ECD-A7B8-45F1-9D88653188D7}"/>
-              </a:ext>
-            </a:extLst>
-          </p:cNvPr>
-          <p:cNvSpPr txBox="1">
-            <a:spLocks noGrp="1"/>
-          </p:cNvSpPr>
-          <p:nvPr>
-            <p:ph type="dt" sz="half" idx="6"/>
-          </p:nvPr>
-        </p:nvSpPr>
-        <p:spPr>
-          <a:prstGeom prst="rect">
-            <a:avLst/>
-          </a:prstGeom>
-        </p:spPr>
-        <p:txBody>
-          <a:bodyPr vert="horz" wrap="square" lIns="0" tIns="3810" rIns="0" bIns="0" rtlCol="0">
-            <a:spAutoFit/>
-          </a:bodyPr>
-          <a:lstStyle/>
-          <a:p>
-            <a:pPr marL="12700">
-              <a:lnSpc>
-                <a:spcPct val="100000"/>
-              </a:lnSpc>
-              <a:spcBef>
-                <a:spcPts val="30"/>
-              </a:spcBef>
-            </a:pPr>
-            <a:r>
-              <a:rPr spc="-10"/>
-              <a:t>Comunícate</a:t>
-            </a:r>
-            <a:r>
-              <a:rPr spc="-20"/>
-              <a:t> </a:t>
-            </a:r>
-            <a:r>
-              <a:t>con</a:t>
-            </a:r>
-            <a:r>
-              <a:rPr spc="-15"/>
-              <a:t> </a:t>
-            </a:r>
-            <a:r>
-              <a:t>nuestras</a:t>
-            </a:r>
-            <a:r>
-              <a:rPr spc="-15"/>
-              <a:t> </a:t>
-            </a:r>
-            <a:r>
-              <a:t>líneas</a:t>
-            </a:r>
-            <a:r>
-              <a:rPr spc="-15"/>
-              <a:t> </a:t>
-            </a:r>
-            <a:r>
-              <a:t>de</a:t>
-            </a:r>
-            <a:r>
-              <a:rPr spc="-20"/>
-              <a:t> </a:t>
-            </a:r>
-            <a:r>
-              <a:t>atención</a:t>
-            </a:r>
-            <a:r>
-              <a:rPr spc="-15"/>
-              <a:t> </a:t>
-            </a:r>
-            <a:r>
-              <a:t>al</a:t>
-            </a:r>
-            <a:r>
-              <a:rPr spc="-15"/>
-              <a:t> </a:t>
-            </a:r>
-            <a:r>
-              <a:rPr spc="-10"/>
-              <a:t>cliente:</a:t>
-            </a:r>
-          </a:p>
-        </p:txBody>
-      </p:sp>
-      <p:sp>
-        <p:nvSpPr>
-          <p:cNvPr id="16491" name="object 16491">
-            <a:extLst>
-              <a:ext uri="{FF2B5EF4-FFF2-40B4-BE49-F238E27FC236}">
-                <a16:creationId xmlns:a16="http://schemas.microsoft.com/office/drawing/2014/main" id="{723FE944-17B8-AB9B-C5F6-9AFEB1193345}"/>
-              </a:ext>
-            </a:extLst>
-          </p:cNvPr>
-          <p:cNvSpPr txBox="1"/>
-          <p:nvPr/>
-        </p:nvSpPr>
-        <p:spPr>
-          <a:xfrm>
-            <a:off x="4697623" y="4152356"/>
-            <a:ext cx="3014980" cy="235321"/>
-          </a:xfrm>
-          <a:prstGeom prst="rect">
-            <a:avLst/>
-          </a:prstGeom>
-        </p:spPr>
-        <p:txBody>
-          <a:bodyPr vert="horz" wrap="square" lIns="0" tIns="4445" rIns="0" bIns="0" rtlCol="0">
-            <a:spAutoFit/>
-          </a:bodyPr>
-          <a:lstStyle/>
-          <a:p>
-            <a:pPr marL="12700">
-              <a:lnSpc>
-                <a:spcPct val="100000"/>
-              </a:lnSpc>
-              <a:spcBef>
-                <a:spcPts val="35"/>
-              </a:spcBef>
-            </a:pPr>
-            <a:r>
-              <a:rPr sz="1500" b="0" spc="-10">
-                <a:solidFill>
-                  <a:schemeClr val="bg1"/>
-                </a:solidFill>
-                <a:latin typeface="Unageo light" pitchFamily="2" charset="0"/>
-                <a:cs typeface="Unageo"/>
-                <a:hlinkClick r:id="rId3">
-                  <a:extLst>
-                    <a:ext uri="{A12FA001-AC4F-418D-AE19-62706E023703}">
-                      <ahyp:hlinkClr xmlns:ahyp="http://schemas.microsoft.com/office/drawing/2018/hyperlinkcolor" val="tx"/>
-                    </a:ext>
-                  </a:extLst>
-                </a:hlinkClick>
-              </a:rPr>
-              <a:t>servicioalcliente@impresistem.com</a:t>
-            </a:r>
-            <a:endParaRPr sz="1500">
-              <a:solidFill>
-                <a:schemeClr val="bg1"/>
-              </a:solidFill>
-              <a:latin typeface="Unageo light" pitchFamily="2" charset="0"/>
-              <a:cs typeface="Unageo"/>
-            </a:endParaRPr>
-          </a:p>
-        </p:txBody>
-      </p:sp>
-      <p:sp>
-        <p:nvSpPr>
-          <p:cNvPr id="16492" name="object 16492">
-            <a:extLst>
-              <a:ext uri="{FF2B5EF4-FFF2-40B4-BE49-F238E27FC236}">
-                <a16:creationId xmlns:a16="http://schemas.microsoft.com/office/drawing/2014/main" id="{834C45AB-8AAD-9540-A3C3-DD9C8CC4A770}"/>
-              </a:ext>
-            </a:extLst>
-          </p:cNvPr>
-          <p:cNvSpPr txBox="1"/>
-          <p:nvPr/>
-        </p:nvSpPr>
-        <p:spPr>
-          <a:xfrm>
-            <a:off x="8583198" y="4158683"/>
-            <a:ext cx="2157730" cy="235321"/>
-          </a:xfrm>
-          <a:prstGeom prst="rect">
-            <a:avLst/>
-          </a:prstGeom>
-        </p:spPr>
-        <p:txBody>
-          <a:bodyPr vert="horz" wrap="square" lIns="0" tIns="4445" rIns="0" bIns="0" rtlCol="0">
-            <a:spAutoFit/>
-          </a:bodyPr>
-          <a:lstStyle/>
-          <a:p>
-            <a:pPr marL="12700">
-              <a:lnSpc>
-                <a:spcPct val="100000"/>
-              </a:lnSpc>
-              <a:spcBef>
-                <a:spcPts val="35"/>
-              </a:spcBef>
-            </a:pPr>
-            <a:r>
-              <a:rPr sz="1500" b="0">
-                <a:solidFill>
-                  <a:srgbClr val="FFFFFF"/>
-                </a:solidFill>
-                <a:latin typeface="Unageo light" pitchFamily="2" charset="0"/>
-                <a:cs typeface="Unageo"/>
-              </a:rPr>
-              <a:t>WhatsApp: 317 430 </a:t>
-            </a:r>
-            <a:r>
-              <a:rPr sz="1500" b="0" spc="-20">
-                <a:solidFill>
-                  <a:srgbClr val="FFFFFF"/>
-                </a:solidFill>
-                <a:latin typeface="Unageo light" pitchFamily="2" charset="0"/>
-                <a:cs typeface="Unageo"/>
-              </a:rPr>
-              <a:t>3907</a:t>
-            </a:r>
-            <a:endParaRPr sz="1500">
-              <a:latin typeface="Unageo light" pitchFamily="2" charset="0"/>
-              <a:cs typeface="Unageo"/>
-            </a:endParaRPr>
-          </a:p>
-        </p:txBody>
-      </p:sp>
-      <p:sp>
-        <p:nvSpPr>
-          <p:cNvPr id="3" name="object 4">
-            <a:extLst>
-              <a:ext uri="{FF2B5EF4-FFF2-40B4-BE49-F238E27FC236}">
-                <a16:creationId xmlns:a16="http://schemas.microsoft.com/office/drawing/2014/main" id="{DB093A61-E504-9540-2ED5-0EEF05D2C95D}"/>
-              </a:ext>
-            </a:extLst>
-          </p:cNvPr>
-          <p:cNvSpPr txBox="1"/>
-          <p:nvPr/>
-        </p:nvSpPr>
-        <p:spPr>
-          <a:xfrm>
-            <a:off x="5235153" y="2958665"/>
-            <a:ext cx="2506980" cy="529590"/>
-          </a:xfrm>
-          <a:prstGeom prst="rect">
-            <a:avLst/>
-          </a:prstGeom>
-        </p:spPr>
-        <p:txBody>
-          <a:bodyPr vert="horz" wrap="square" lIns="0" tIns="15240" rIns="0" bIns="0" rtlCol="0">
-            <a:spAutoFit/>
-          </a:bodyPr>
-          <a:lstStyle/>
-          <a:p>
-            <a:pPr marL="12700">
-              <a:lnSpc>
-                <a:spcPts val="2395"/>
-              </a:lnSpc>
-              <a:spcBef>
-                <a:spcPts val="120"/>
-              </a:spcBef>
-            </a:pPr>
-            <a:r>
-              <a:rPr sz="2050" dirty="0">
-                <a:latin typeface="Unageo light" pitchFamily="2" charset="0"/>
-                <a:cs typeface="Unageo"/>
-              </a:rPr>
-              <a:t>Calle</a:t>
-            </a:r>
-            <a:r>
-              <a:rPr sz="2050" spc="10" dirty="0">
-                <a:latin typeface="Unageo light" pitchFamily="2" charset="0"/>
-                <a:cs typeface="Unageo"/>
-              </a:rPr>
-              <a:t> </a:t>
-            </a:r>
-            <a:r>
-              <a:rPr sz="2050" dirty="0">
-                <a:latin typeface="Unageo light" pitchFamily="2" charset="0"/>
-                <a:cs typeface="Unageo"/>
-              </a:rPr>
-              <a:t>80</a:t>
-            </a:r>
-            <a:r>
-              <a:rPr sz="2050" spc="10" dirty="0">
-                <a:latin typeface="Unageo light" pitchFamily="2" charset="0"/>
-                <a:cs typeface="Unageo"/>
-              </a:rPr>
-              <a:t> </a:t>
-            </a:r>
-            <a:r>
-              <a:rPr sz="2050" dirty="0">
-                <a:latin typeface="Unageo light" pitchFamily="2" charset="0"/>
-                <a:cs typeface="Unageo"/>
-              </a:rPr>
-              <a:t>Km</a:t>
-            </a:r>
-            <a:r>
-              <a:rPr sz="2050" spc="15" dirty="0">
-                <a:latin typeface="Unageo light" pitchFamily="2" charset="0"/>
-                <a:cs typeface="Unageo"/>
-              </a:rPr>
-              <a:t> </a:t>
-            </a:r>
-            <a:r>
-              <a:rPr sz="2050" dirty="0">
-                <a:latin typeface="Unageo light" pitchFamily="2" charset="0"/>
-                <a:cs typeface="Unageo"/>
-              </a:rPr>
-              <a:t>2</a:t>
-            </a:r>
-            <a:r>
-              <a:rPr sz="2050" spc="10" dirty="0">
-                <a:latin typeface="Unageo light" pitchFamily="2" charset="0"/>
-                <a:cs typeface="Unageo"/>
-              </a:rPr>
-              <a:t> </a:t>
-            </a:r>
-            <a:r>
-              <a:rPr sz="2050" dirty="0">
-                <a:latin typeface="Unageo light" pitchFamily="2" charset="0"/>
-                <a:cs typeface="Unageo"/>
-              </a:rPr>
-              <a:t>-</a:t>
-            </a:r>
-            <a:r>
-              <a:rPr sz="2050" spc="10" dirty="0">
-                <a:latin typeface="Unageo light" pitchFamily="2" charset="0"/>
-                <a:cs typeface="Unageo"/>
-              </a:rPr>
-              <a:t> </a:t>
-            </a:r>
-            <a:r>
-              <a:rPr sz="2050" spc="-20" dirty="0">
-                <a:latin typeface="Unageo light" pitchFamily="2" charset="0"/>
-                <a:cs typeface="Unageo"/>
-              </a:rPr>
-              <a:t>Cota</a:t>
-            </a:r>
-            <a:endParaRPr sz="2050" dirty="0">
-              <a:latin typeface="Unageo light" pitchFamily="2" charset="0"/>
-              <a:cs typeface="Unageo"/>
-            </a:endParaRPr>
-          </a:p>
-          <a:p>
-            <a:pPr marL="12700">
-              <a:lnSpc>
-                <a:spcPts val="1555"/>
-              </a:lnSpc>
-            </a:pPr>
-            <a:r>
-              <a:rPr sz="1350" dirty="0">
-                <a:latin typeface="Unageo light" pitchFamily="2" charset="0"/>
-                <a:cs typeface="Unageo"/>
-              </a:rPr>
-              <a:t>Parque Empresarial </a:t>
-            </a:r>
-            <a:r>
-              <a:rPr sz="1350" spc="-10" dirty="0">
-                <a:latin typeface="Unageo light" pitchFamily="2" charset="0"/>
-                <a:cs typeface="Unageo"/>
-              </a:rPr>
-              <a:t>Tecnológico</a:t>
-            </a:r>
-            <a:endParaRPr sz="1350" dirty="0">
-              <a:latin typeface="Unageo light" pitchFamily="2" charset="0"/>
-              <a:cs typeface="Unageo"/>
-            </a:endParaRPr>
-          </a:p>
-        </p:txBody>
-      </p:sp>
       <p:grpSp>
         <p:nvGrpSpPr>
           <p:cNvPr id="11" name="object 5">
@@ -3841,7 +3428,7 @@
             <p:nvPr/>
           </p:nvPicPr>
           <p:blipFill>
-            <a:blip r:embed="rId4" cstate="print"/>
+            <a:blip r:embed="rId3" cstate="print"/>
             <a:stretch>
               <a:fillRect/>
             </a:stretch>
@@ -3857,6 +3444,424 @@
           </p:spPr>
         </p:pic>
       </p:grpSp>
+      <p:sp>
+        <p:nvSpPr>
+          <p:cNvPr id="2" name="object 16493">
+            <a:extLst>
+              <a:ext uri="{FF2B5EF4-FFF2-40B4-BE49-F238E27FC236}">
+                <a16:creationId xmlns:a16="http://schemas.microsoft.com/office/drawing/2014/main" id="{50FA69C8-937C-A962-C71A-2580DF7C4BE2}"/>
+              </a:ext>
+            </a:extLst>
+          </p:cNvPr>
+          <p:cNvSpPr txBox="1">
+            <a:spLocks noGrp="1"/>
+          </p:cNvSpPr>
+          <p:nvPr>
+            <p:ph type="ftr" sz="quarter" idx="5"/>
+          </p:nvPr>
+        </p:nvSpPr>
+        <p:spPr>
+          <a:xfrm>
+            <a:off x="2357945" y="4164094"/>
+            <a:ext cx="1634489" cy="235321"/>
+          </a:xfrm>
+          <a:prstGeom prst="rect">
+            <a:avLst/>
+          </a:prstGeom>
+        </p:spPr>
+        <p:txBody>
+          <a:bodyPr vert="horz" wrap="square" lIns="0" tIns="4445" rIns="0" bIns="0" rtlCol="0">
+            <a:spAutoFit/>
+          </a:bodyPr>
+          <a:lstStyle/>
+          <a:p>
+            <a:pPr marL="12700">
+              <a:lnSpc>
+                <a:spcPct val="100000"/>
+              </a:lnSpc>
+              <a:spcBef>
+                <a:spcPts val="35"/>
+              </a:spcBef>
+            </a:pPr>
+            <a:r>
+              <a:rPr>
+                <a:latin typeface="Unageo light" pitchFamily="2" charset="0"/>
+              </a:rPr>
+              <a:t>601 8766500 Ext. </a:t>
+            </a:r>
+            <a:r>
+              <a:rPr spc="-50">
+                <a:latin typeface="Unageo light" pitchFamily="2" charset="0"/>
+              </a:rPr>
+              <a:t>2</a:t>
+            </a:r>
+          </a:p>
+        </p:txBody>
+      </p:sp>
+      <p:sp>
+        <p:nvSpPr>
+          <p:cNvPr id="3" name="object 16490">
+            <a:extLst>
+              <a:ext uri="{FF2B5EF4-FFF2-40B4-BE49-F238E27FC236}">
+                <a16:creationId xmlns:a16="http://schemas.microsoft.com/office/drawing/2014/main" id="{3E47BAA0-5DAB-AF27-8419-CB4D1FB09CDB}"/>
+              </a:ext>
+            </a:extLst>
+          </p:cNvPr>
+          <p:cNvSpPr txBox="1">
+            <a:spLocks noGrp="1"/>
+          </p:cNvSpPr>
+          <p:nvPr>
+            <p:ph type="dt" sz="half" idx="6"/>
+          </p:nvPr>
+        </p:nvSpPr>
+        <p:spPr>
+          <a:xfrm>
+            <a:off x="7020086" y="3812594"/>
+            <a:ext cx="4268470" cy="231139"/>
+          </a:xfrm>
+          <a:prstGeom prst="rect">
+            <a:avLst/>
+          </a:prstGeom>
+        </p:spPr>
+        <p:txBody>
+          <a:bodyPr vert="horz" wrap="square" lIns="0" tIns="3810" rIns="0" bIns="0" rtlCol="0">
+            <a:spAutoFit/>
+          </a:bodyPr>
+          <a:lstStyle/>
+          <a:p>
+            <a:pPr marL="12700">
+              <a:lnSpc>
+                <a:spcPct val="100000"/>
+              </a:lnSpc>
+              <a:spcBef>
+                <a:spcPts val="30"/>
+              </a:spcBef>
+            </a:pPr>
+            <a:r>
+              <a:rPr spc="-10"/>
+              <a:t>Comunícate</a:t>
+            </a:r>
+            <a:r>
+              <a:rPr spc="-20"/>
+              <a:t> </a:t>
+            </a:r>
+            <a:r>
+              <a:t>con</a:t>
+            </a:r>
+            <a:r>
+              <a:rPr spc="-15"/>
+              <a:t> </a:t>
+            </a:r>
+            <a:r>
+              <a:t>nuestras</a:t>
+            </a:r>
+            <a:r>
+              <a:rPr spc="-15"/>
+              <a:t> </a:t>
+            </a:r>
+            <a:r>
+              <a:t>líneas</a:t>
+            </a:r>
+            <a:r>
+              <a:rPr spc="-15"/>
+              <a:t> </a:t>
+            </a:r>
+            <a:r>
+              <a:t>de</a:t>
+            </a:r>
+            <a:r>
+              <a:rPr spc="-20"/>
+              <a:t> </a:t>
+            </a:r>
+            <a:r>
+              <a:t>atención</a:t>
+            </a:r>
+            <a:r>
+              <a:rPr spc="-15"/>
+              <a:t> </a:t>
+            </a:r>
+            <a:r>
+              <a:t>al</a:t>
+            </a:r>
+            <a:r>
+              <a:rPr spc="-15"/>
+              <a:t> </a:t>
+            </a:r>
+            <a:r>
+              <a:rPr spc="-10"/>
+              <a:t>cliente:</a:t>
+            </a:r>
+          </a:p>
+        </p:txBody>
+      </p:sp>
+      <p:sp>
+        <p:nvSpPr>
+          <p:cNvPr id="4" name="object 16491">
+            <a:extLst>
+              <a:ext uri="{FF2B5EF4-FFF2-40B4-BE49-F238E27FC236}">
+                <a16:creationId xmlns:a16="http://schemas.microsoft.com/office/drawing/2014/main" id="{BF5BF0C7-8837-9B3D-B070-7EC8C7D06816}"/>
+              </a:ext>
+            </a:extLst>
+          </p:cNvPr>
+          <p:cNvSpPr txBox="1"/>
+          <p:nvPr/>
+        </p:nvSpPr>
+        <p:spPr>
+          <a:xfrm>
+            <a:off x="4697623" y="4152356"/>
+            <a:ext cx="3014980" cy="235321"/>
+          </a:xfrm>
+          <a:prstGeom prst="rect">
+            <a:avLst/>
+          </a:prstGeom>
+        </p:spPr>
+        <p:txBody>
+          <a:bodyPr vert="horz" wrap="square" lIns="0" tIns="4445" rIns="0" bIns="0" rtlCol="0">
+            <a:spAutoFit/>
+          </a:bodyPr>
+          <a:lstStyle/>
+          <a:p>
+            <a:pPr marL="12700">
+              <a:lnSpc>
+                <a:spcPct val="100000"/>
+              </a:lnSpc>
+              <a:spcBef>
+                <a:spcPts val="35"/>
+              </a:spcBef>
+            </a:pPr>
+            <a:r>
+              <a:rPr sz="1500" b="0" spc="-10">
+                <a:solidFill>
+                  <a:schemeClr val="bg1"/>
+                </a:solidFill>
+                <a:latin typeface="Unageo light" pitchFamily="2" charset="0"/>
+                <a:cs typeface="Unageo"/>
+                <a:hlinkClick r:id="rId4">
+                  <a:extLst>
+                    <a:ext uri="{A12FA001-AC4F-418D-AE19-62706E023703}">
+                      <ahyp:hlinkClr xmlns:ahyp="http://schemas.microsoft.com/office/drawing/2018/hyperlinkcolor" val="tx"/>
+                    </a:ext>
+                  </a:extLst>
+                </a:hlinkClick>
+              </a:rPr>
+              <a:t>servicioalcliente@impresistem.com</a:t>
+            </a:r>
+            <a:endParaRPr sz="1500">
+              <a:solidFill>
+                <a:schemeClr val="bg1"/>
+              </a:solidFill>
+              <a:latin typeface="Unageo light" pitchFamily="2" charset="0"/>
+              <a:cs typeface="Unageo"/>
+            </a:endParaRPr>
+          </a:p>
+        </p:txBody>
+      </p:sp>
+      <p:sp>
+        <p:nvSpPr>
+          <p:cNvPr id="5" name="object 16492">
+            <a:extLst>
+              <a:ext uri="{FF2B5EF4-FFF2-40B4-BE49-F238E27FC236}">
+                <a16:creationId xmlns:a16="http://schemas.microsoft.com/office/drawing/2014/main" id="{401C17F8-B423-7634-AF99-3201997316AF}"/>
+              </a:ext>
+            </a:extLst>
+          </p:cNvPr>
+          <p:cNvSpPr txBox="1"/>
+          <p:nvPr/>
+        </p:nvSpPr>
+        <p:spPr>
+          <a:xfrm>
+            <a:off x="8583198" y="4158683"/>
+            <a:ext cx="2157730" cy="235321"/>
+          </a:xfrm>
+          <a:prstGeom prst="rect">
+            <a:avLst/>
+          </a:prstGeom>
+        </p:spPr>
+        <p:txBody>
+          <a:bodyPr vert="horz" wrap="square" lIns="0" tIns="4445" rIns="0" bIns="0" rtlCol="0">
+            <a:spAutoFit/>
+          </a:bodyPr>
+          <a:lstStyle/>
+          <a:p>
+            <a:pPr marL="12700">
+              <a:lnSpc>
+                <a:spcPct val="100000"/>
+              </a:lnSpc>
+              <a:spcBef>
+                <a:spcPts val="35"/>
+              </a:spcBef>
+            </a:pPr>
+            <a:r>
+              <a:rPr sz="1500" b="0">
+                <a:solidFill>
+                  <a:srgbClr val="FFFFFF"/>
+                </a:solidFill>
+                <a:latin typeface="Unageo light" pitchFamily="2" charset="0"/>
+                <a:cs typeface="Unageo"/>
+              </a:rPr>
+              <a:t>WhatsApp: 317 430 </a:t>
+            </a:r>
+            <a:r>
+              <a:rPr sz="1500" b="0" spc="-20">
+                <a:solidFill>
+                  <a:srgbClr val="FFFFFF"/>
+                </a:solidFill>
+                <a:latin typeface="Unageo light" pitchFamily="2" charset="0"/>
+                <a:cs typeface="Unageo"/>
+              </a:rPr>
+              <a:t>3907</a:t>
+            </a:r>
+            <a:endParaRPr sz="1500">
+              <a:latin typeface="Unageo light" pitchFamily="2" charset="0"/>
+              <a:cs typeface="Unageo"/>
+            </a:endParaRPr>
+          </a:p>
+        </p:txBody>
+      </p:sp>
+      <p:sp>
+        <p:nvSpPr>
+          <p:cNvPr id="6" name="object 4">
+            <a:extLst>
+              <a:ext uri="{FF2B5EF4-FFF2-40B4-BE49-F238E27FC236}">
+                <a16:creationId xmlns:a16="http://schemas.microsoft.com/office/drawing/2014/main" id="{DA8F613C-11D5-3F98-4292-3B66597F526E}"/>
+              </a:ext>
+            </a:extLst>
+          </p:cNvPr>
+          <p:cNvSpPr txBox="1"/>
+          <p:nvPr/>
+        </p:nvSpPr>
+        <p:spPr>
+          <a:xfrm>
+            <a:off x="5165932" y="3020347"/>
+            <a:ext cx="2506980" cy="529590"/>
+          </a:xfrm>
+          <a:prstGeom prst="rect">
+            <a:avLst/>
+          </a:prstGeom>
+        </p:spPr>
+        <p:txBody>
+          <a:bodyPr vert="horz" wrap="square" lIns="0" tIns="15240" rIns="0" bIns="0" rtlCol="0">
+            <a:spAutoFit/>
+          </a:bodyPr>
+          <a:lstStyle/>
+          <a:p>
+            <a:pPr marL="12700">
+              <a:lnSpc>
+                <a:spcPts val="2395"/>
+              </a:lnSpc>
+              <a:spcBef>
+                <a:spcPts val="120"/>
+              </a:spcBef>
+            </a:pPr>
+            <a:r>
+              <a:rPr sz="2050" dirty="0">
+                <a:latin typeface="Unageo light" pitchFamily="2" charset="0"/>
+                <a:cs typeface="Unageo"/>
+              </a:rPr>
+              <a:t>Calle</a:t>
+            </a:r>
+            <a:r>
+              <a:rPr sz="2050" spc="10" dirty="0">
+                <a:latin typeface="Unageo light" pitchFamily="2" charset="0"/>
+                <a:cs typeface="Unageo"/>
+              </a:rPr>
+              <a:t> </a:t>
+            </a:r>
+            <a:r>
+              <a:rPr sz="2050" dirty="0">
+                <a:latin typeface="Unageo light" pitchFamily="2" charset="0"/>
+                <a:cs typeface="Unageo"/>
+              </a:rPr>
+              <a:t>80</a:t>
+            </a:r>
+            <a:r>
+              <a:rPr sz="2050" spc="10" dirty="0">
+                <a:latin typeface="Unageo light" pitchFamily="2" charset="0"/>
+                <a:cs typeface="Unageo"/>
+              </a:rPr>
+              <a:t> </a:t>
+            </a:r>
+            <a:r>
+              <a:rPr sz="2050" dirty="0">
+                <a:latin typeface="Unageo light" pitchFamily="2" charset="0"/>
+                <a:cs typeface="Unageo"/>
+              </a:rPr>
+              <a:t>Km</a:t>
+            </a:r>
+            <a:r>
+              <a:rPr sz="2050" spc="15" dirty="0">
+                <a:latin typeface="Unageo light" pitchFamily="2" charset="0"/>
+                <a:cs typeface="Unageo"/>
+              </a:rPr>
+              <a:t> </a:t>
+            </a:r>
+            <a:r>
+              <a:rPr sz="2050" dirty="0">
+                <a:latin typeface="Unageo light" pitchFamily="2" charset="0"/>
+                <a:cs typeface="Unageo"/>
+              </a:rPr>
+              <a:t>2</a:t>
+            </a:r>
+            <a:r>
+              <a:rPr sz="2050" spc="10" dirty="0">
+                <a:latin typeface="Unageo light" pitchFamily="2" charset="0"/>
+                <a:cs typeface="Unageo"/>
+              </a:rPr>
+              <a:t> </a:t>
+            </a:r>
+            <a:r>
+              <a:rPr sz="2050" dirty="0">
+                <a:latin typeface="Unageo light" pitchFamily="2" charset="0"/>
+                <a:cs typeface="Unageo"/>
+              </a:rPr>
+              <a:t>-</a:t>
+            </a:r>
+            <a:r>
+              <a:rPr sz="2050" spc="10" dirty="0">
+                <a:latin typeface="Unageo light" pitchFamily="2" charset="0"/>
+                <a:cs typeface="Unageo"/>
+              </a:rPr>
+              <a:t> </a:t>
+            </a:r>
+            <a:r>
+              <a:rPr sz="2050" spc="-20" dirty="0">
+                <a:latin typeface="Unageo light" pitchFamily="2" charset="0"/>
+                <a:cs typeface="Unageo"/>
+              </a:rPr>
+              <a:t>Cota</a:t>
+            </a:r>
+            <a:endParaRPr sz="2050" dirty="0">
+              <a:latin typeface="Unageo light" pitchFamily="2" charset="0"/>
+              <a:cs typeface="Unageo"/>
+            </a:endParaRPr>
+          </a:p>
+          <a:p>
+            <a:pPr marL="12700">
+              <a:lnSpc>
+                <a:spcPts val="1555"/>
+              </a:lnSpc>
+            </a:pPr>
+            <a:r>
+              <a:rPr sz="1350" dirty="0">
+                <a:latin typeface="Unageo light" pitchFamily="2" charset="0"/>
+                <a:cs typeface="Unageo"/>
+              </a:rPr>
+              <a:t>Parque Empresarial </a:t>
+            </a:r>
+            <a:r>
+              <a:rPr sz="1350" spc="-10" dirty="0">
+                <a:latin typeface="Unageo light" pitchFamily="2" charset="0"/>
+                <a:cs typeface="Unageo"/>
+              </a:rPr>
+              <a:t>Tecnológico</a:t>
+            </a:r>
+            <a:endParaRPr sz="1350" dirty="0">
+              <a:latin typeface="Unageo light" pitchFamily="2" charset="0"/>
+              <a:cs typeface="Unageo"/>
+            </a:endParaRPr>
+          </a:p>
+        </p:txBody>
+      </p:sp>
     </p:spTree>
     <p:extLst>
       <p:ext uri="{BB962C8B-B14F-4D97-AF65-F5344CB8AC3E}">

</xml_diff>